<commit_message>
fixed a bug in the source code
</commit_message>
<xml_diff>
--- a/week06/Lecture06.pptx
+++ b/week06/Lecture06.pptx
@@ -539,7 +539,7 @@
           <a:p>
             <a:fld id="{634F3F22-B4BB-3F48-9180-464A9F2D66D1}" type="datetimeFigureOut">
               <a:rPr kumimoji="1" lang="zh-CN" altLang="en-US" smtClean="0"/>
-              <a:t>2026/4/6</a:t>
+              <a:t>2026/4/7</a:t>
             </a:fld>
             <a:endParaRPr kumimoji="1" lang="zh-CN" altLang="en-US"/>
           </a:p>
@@ -1019,7 +1019,7 @@
           <a:p>
             <a:fld id="{FC19A4FA-3D9A-4114-B0D5-759CBD56F1AB}" type="datetimeFigureOut">
               <a:rPr lang="zh-CN" altLang="en-US" smtClean="0"/>
-              <a:t>2026/4/6</a:t>
+              <a:t>2026/4/7</a:t>
             </a:fld>
             <a:endParaRPr lang="zh-CN" altLang="en-US"/>
           </a:p>
@@ -1222,7 +1222,7 @@
           <a:p>
             <a:fld id="{FC19A4FA-3D9A-4114-B0D5-759CBD56F1AB}" type="datetimeFigureOut">
               <a:rPr lang="zh-CN" altLang="en-US" smtClean="0"/>
-              <a:t>2026/4/6</a:t>
+              <a:t>2026/4/7</a:t>
             </a:fld>
             <a:endParaRPr lang="zh-CN" altLang="en-US"/>
           </a:p>
@@ -1400,7 +1400,7 @@
           <a:p>
             <a:fld id="{FC19A4FA-3D9A-4114-B0D5-759CBD56F1AB}" type="datetimeFigureOut">
               <a:rPr lang="zh-CN" altLang="en-US" smtClean="0"/>
-              <a:t>2026/4/6</a:t>
+              <a:t>2026/4/7</a:t>
             </a:fld>
             <a:endParaRPr lang="zh-CN" altLang="en-US"/>
           </a:p>
@@ -1624,7 +1624,7 @@
           <a:p>
             <a:fld id="{FC19A4FA-3D9A-4114-B0D5-759CBD56F1AB}" type="datetimeFigureOut">
               <a:rPr lang="zh-CN" altLang="en-US" smtClean="0"/>
-              <a:t>2026/4/6</a:t>
+              <a:t>2026/4/7</a:t>
             </a:fld>
             <a:endParaRPr lang="zh-CN" altLang="en-US"/>
           </a:p>
@@ -1858,7 +1858,7 @@
           <a:p>
             <a:fld id="{FC19A4FA-3D9A-4114-B0D5-759CBD56F1AB}" type="datetimeFigureOut">
               <a:rPr lang="zh-CN" altLang="en-US" smtClean="0"/>
-              <a:t>2026/4/6</a:t>
+              <a:t>2026/4/7</a:t>
             </a:fld>
             <a:endParaRPr lang="zh-CN" altLang="en-US"/>
           </a:p>
@@ -2257,7 +2257,7 @@
           <a:p>
             <a:fld id="{FC19A4FA-3D9A-4114-B0D5-759CBD56F1AB}" type="datetimeFigureOut">
               <a:rPr lang="zh-CN" altLang="en-US" smtClean="0"/>
-              <a:t>2026/4/6</a:t>
+              <a:t>2026/4/7</a:t>
             </a:fld>
             <a:endParaRPr lang="zh-CN" altLang="en-US"/>
           </a:p>
@@ -2537,7 +2537,7 @@
           <a:p>
             <a:fld id="{FC19A4FA-3D9A-4114-B0D5-759CBD56F1AB}" type="datetimeFigureOut">
               <a:rPr lang="zh-CN" altLang="en-US" smtClean="0"/>
-              <a:t>2026/4/6</a:t>
+              <a:t>2026/4/7</a:t>
             </a:fld>
             <a:endParaRPr lang="zh-CN" altLang="en-US"/>
           </a:p>
@@ -2689,7 +2689,7 @@
           <a:p>
             <a:fld id="{FC19A4FA-3D9A-4114-B0D5-759CBD56F1AB}" type="datetimeFigureOut">
               <a:rPr lang="zh-CN" altLang="en-US" smtClean="0"/>
-              <a:t>2026/4/6</a:t>
+              <a:t>2026/4/7</a:t>
             </a:fld>
             <a:endParaRPr lang="zh-CN" altLang="en-US"/>
           </a:p>
@@ -2819,7 +2819,7 @@
           <a:p>
             <a:fld id="{FC19A4FA-3D9A-4114-B0D5-759CBD56F1AB}" type="datetimeFigureOut">
               <a:rPr lang="zh-CN" altLang="en-US" smtClean="0"/>
-              <a:t>2026/4/6</a:t>
+              <a:t>2026/4/7</a:t>
             </a:fld>
             <a:endParaRPr lang="zh-CN" altLang="en-US"/>
           </a:p>
@@ -3129,7 +3129,7 @@
           <a:p>
             <a:fld id="{FC19A4FA-3D9A-4114-B0D5-759CBD56F1AB}" type="datetimeFigureOut">
               <a:rPr lang="zh-CN" altLang="en-US" smtClean="0"/>
-              <a:t>2026/4/6</a:t>
+              <a:t>2026/4/7</a:t>
             </a:fld>
             <a:endParaRPr lang="zh-CN" altLang="en-US"/>
           </a:p>
@@ -3416,7 +3416,7 @@
           <a:p>
             <a:fld id="{FC19A4FA-3D9A-4114-B0D5-759CBD56F1AB}" type="datetimeFigureOut">
               <a:rPr lang="zh-CN" altLang="en-US" smtClean="0"/>
-              <a:t>2026/4/6</a:t>
+              <a:t>2026/4/7</a:t>
             </a:fld>
             <a:endParaRPr lang="zh-CN" altLang="en-US"/>
           </a:p>
@@ -3709,7 +3709,7 @@
           <a:p>
             <a:fld id="{FC19A4FA-3D9A-4114-B0D5-759CBD56F1AB}" type="datetimeFigureOut">
               <a:rPr lang="zh-CN" altLang="en-US" smtClean="0"/>
-              <a:t>2026/4/6</a:t>
+              <a:t>2026/4/7</a:t>
             </a:fld>
             <a:endParaRPr lang="zh-CN" altLang="en-US"/>
           </a:p>
@@ -7135,7 +7135,7 @@
                 </a:solidFill>
                 <a:latin typeface="Menlo" panose="020B0609030804020204" pitchFamily="49" charset="0"/>
               </a:rPr>
-              <a:t>FLT_MIN</a:t>
+              <a:t>-FLT_MAX</a:t>
             </a:r>
             <a:r>
               <a:rPr lang="en" altLang="zh-CN" dirty="0">
@@ -14333,7 +14333,7 @@
                 </a:solidFill>
                 <a:latin typeface="Menlo" panose="020B0609030804020204" pitchFamily="49" charset="0"/>
               </a:rPr>
-              <a:t>FLT_MIN</a:t>
+              <a:t>-FLT_MAX</a:t>
             </a:r>
             <a:r>
               <a:rPr lang="en" altLang="zh-CN" sz="1400" dirty="0">
@@ -27174,10 +27174,10 @@
       </p:grpSpPr>
       <p:pic>
         <p:nvPicPr>
-          <p:cNvPr id="10" name="图片 9">
+          <p:cNvPr id="4" name="图片 3">
             <a:extLst>
               <a:ext uri="{FF2B5EF4-FFF2-40B4-BE49-F238E27FC236}">
-                <a16:creationId xmlns:a16="http://schemas.microsoft.com/office/drawing/2014/main" id="{7F164FED-9CF1-5770-FA1D-E6147C1B283F}"/>
+                <a16:creationId xmlns:a16="http://schemas.microsoft.com/office/drawing/2014/main" id="{468EF0FA-532F-FD0A-9BF7-33F8220DCE90}"/>
               </a:ext>
             </a:extLst>
           </p:cNvPr>
@@ -27194,8 +27194,8 @@
         </p:blipFill>
         <p:spPr>
           <a:xfrm>
-            <a:off x="6452451" y="2062925"/>
-            <a:ext cx="5439628" cy="4795076"/>
+            <a:off x="6224587" y="2069183"/>
+            <a:ext cx="4979487" cy="4385848"/>
           </a:xfrm>
           <a:prstGeom prst="rect">
             <a:avLst/>
@@ -27292,7 +27292,7 @@
         </p:nvGrpSpPr>
         <p:grpSpPr>
           <a:xfrm>
-            <a:off x="9791393" y="2694448"/>
+            <a:off x="9791393" y="2469480"/>
             <a:ext cx="1006920" cy="1128240"/>
             <a:chOff x="9889365" y="2855662"/>
             <a:chExt cx="1006920" cy="1128240"/>
@@ -27403,10 +27403,10 @@
       </p:grpSp>
       <p:pic>
         <p:nvPicPr>
-          <p:cNvPr id="9" name="图片 8">
+          <p:cNvPr id="5" name="图片 4">
             <a:extLst>
               <a:ext uri="{FF2B5EF4-FFF2-40B4-BE49-F238E27FC236}">
-                <a16:creationId xmlns:a16="http://schemas.microsoft.com/office/drawing/2014/main" id="{0E42D341-4A27-BA36-4F3A-8BB80016C436}"/>
+                <a16:creationId xmlns:a16="http://schemas.microsoft.com/office/drawing/2014/main" id="{AFBBB856-6D13-5438-50A0-A914A6B4552F}"/>
               </a:ext>
             </a:extLst>
           </p:cNvPr>
@@ -27423,12 +27423,13 @@
         </p:blipFill>
         <p:spPr>
           <a:xfrm>
-            <a:off x="571668" y="2069184"/>
-            <a:ext cx="5439628" cy="4788815"/>
+            <a:off x="842761" y="2069183"/>
+            <a:ext cx="4979487" cy="4352637"/>
           </a:xfrm>
           <a:prstGeom prst="rect">
             <a:avLst/>
           </a:prstGeom>
+          <a:noFill/>
           <a:ln>
             <a:solidFill>
               <a:schemeClr val="accent6"/>
@@ -27738,7 +27739,7 @@
                 </a:solidFill>
                 <a:latin typeface="Menlo" panose="020B0609030804020204" pitchFamily="49" charset="0"/>
               </a:rPr>
-              <a:t>FLT_MIN</a:t>
+              <a:t>-FLT_MAX</a:t>
             </a:r>
             <a:r>
               <a:rPr lang="en" altLang="zh-CN" dirty="0">
@@ -35700,7 +35701,7 @@
                 </a:solidFill>
                 <a:latin typeface="Menlo" panose="020B0609030804020204" pitchFamily="49" charset="0"/>
               </a:rPr>
-              <a:t>FLT_MIN</a:t>
+              <a:t>-FLT_MAX</a:t>
             </a:r>
             <a:r>
               <a:rPr lang="en" altLang="zh-CN" dirty="0">
@@ -36981,7 +36982,7 @@
                 </a:solidFill>
                 <a:latin typeface="Menlo" panose="020B0609030804020204" pitchFamily="49" charset="0"/>
               </a:rPr>
-              <a:t>FLT_MIN</a:t>
+              <a:t>-FLT_MAX</a:t>
             </a:r>
             <a:r>
               <a:rPr lang="en" altLang="zh-CN" dirty="0">

</xml_diff>